<commit_message>
Auto-build slides from docs/slides/*.md
Generated HTML, PDF, and PPTX with GitHub Actions
</commit_message>
<xml_diff>
--- a/docs/slides/lightning-talk.pptx
+++ b/docs/slides/lightning-talk.pptx
@@ -16,9 +16,10 @@
     <p:sldId id="264" r:id="rId10"/>
     <p:sldId id="265" r:id="rId11"/>
     <p:sldId id="266" r:id="rId12"/>
+    <p:sldId id="267" r:id="rId13"/>
   </p:sldIdLst>
   <p:notesMasterIdLst>
-    <p:notesMasterId r:id="rId13"/>
+    <p:notesMasterId r:id="rId14"/>
   </p:notesMasterIdLst>
   <p:sldSz cx="12192000" cy="6858000"/>
   <p:notesSz cx="6858000" cy="12192000"/>
@@ -512,7 +513,7 @@
           <a:p>
             <a:r>
               <a:rPr lang="en-US" dirty="0"/>
-              <a:t>Hi, I'm Jason, and this is my first PyCon. I work in IT for a community college here in California. This talk is about what I do when I'm supposed to be relaxing: 3D printing little mechanical things and then overthinking them. I wanted something physical to hand people here, so I made a business card with a gear mechanism in it. If I gave you one, you're holding it.</a:t>
+              <a:t>[walk up, hold up the card if you have one]</a:t>
             </a:r>
             <a:endParaRPr lang="en-US" dirty="0"/>
           </a:p>
@@ -600,7 +601,7 @@
           <a:p>
             <a:r>
               <a:rPr lang="en-US" dirty="0"/>
-              <a:t>If any of this sounds interesting — Python gluing into CAD, print-in-place mechanisms, or whether CC BY-SA is the right license for a mechanical STEP file — come find me. I will talk about it much longer than five minutes.</a:t>
+              <a:t/>
             </a:r>
             <a:endParaRPr lang="en-US" dirty="0"/>
           </a:p>
@@ -688,7 +689,9 @@
           <a:p>
             <a:r>
               <a:rPr lang="en-US" dirty="0"/>
-              <a:t>Scan this or search my GitHub handle. I have physical cards — ask me for one. Thanks.</a:t>
+              <a:t>Physical open-source projects can borrow some habits from software. Version control. Generated documentation. Repeatable builds. Reviewable changes. Public artifacts. And maybe even little sanity checks that help the object explain itself.
+I am also interested in the licensing side of this. For code, we have a pretty familiar set of open-source licenses. For 3D design files, especially functional objects, I am less sure what the right answer is. Does Creative Commons make sense for STEP files? Is CC BY-SA the right model? What does sharing mean when someone can download the geometry, modify it, print it, remix it, or manufacture it?
+I do not have a perfect answer to that. But it is one of the reasons I like having the project public. It makes those questions part of the project instead of something I figure out later in private.</a:t>
             </a:r>
             <a:endParaRPr lang="en-US" dirty="0"/>
           </a:p>
@@ -712,6 +715,96 @@
             <a:fld id="{F7021451-1387-4CA6-816F-3879F97B5CBC}" type="slidenum">
               <a:rPr lang="en-US"/>
               <a:t>11</a:t>
+            </a:fld>
+            <a:endParaRPr lang="en-US"/>
+          </a:p>
+        </p:txBody>
+      </p:sp>
+    </p:spTree>
+    <p:extLst>
+      <p:ext uri="{BB962C8B-B14F-4D97-AF65-F5344CB8AC3E}">
+        <p14:creationId xmlns:p14="http://schemas.microsoft.com/office/powerpoint/2010/main" val="1024086991"/>
+      </p:ext>
+    </p:extLst>
+  </p:cSld>
+  <p:clrMapOvr>
+    <a:masterClrMapping/>
+  </p:clrMapOvr>
+</p:notes>
+</file>
+
+<file path=ppt/notesSlides/notesSlide12.xml><?xml version="1.0" encoding="utf-8"?>
+<p:notes xmlns:a="http://schemas.openxmlformats.org/drawingml/2006/main" xmlns:r="http://schemas.openxmlformats.org/officeDocument/2006/relationships" xmlns:p="http://schemas.openxmlformats.org/presentationml/2006/main">
+  <p:cSld>
+    <p:spTree>
+      <p:nvGrpSpPr>
+        <p:cNvPr id="1" name=""/>
+        <p:cNvGrpSpPr/>
+        <p:nvPr/>
+      </p:nvGrpSpPr>
+      <p:grpSpPr>
+        <a:xfrm>
+          <a:off x="0" y="0"/>
+          <a:ext cx="0" cy="0"/>
+          <a:chOff x="0" y="0"/>
+          <a:chExt cx="0" cy="0"/>
+        </a:xfrm>
+      </p:grpSpPr>
+      <p:sp>
+        <p:nvSpPr>
+          <p:cNvPr id="2" name="Slide Image Placeholder 1"/>
+          <p:cNvSpPr>
+            <a:spLocks noGrp="1" noRot="1" noChangeAspect="1"/>
+          </p:cNvSpPr>
+          <p:nvPr>
+            <p:ph type="sldImg"/>
+          </p:nvPr>
+        </p:nvSpPr>
+        <p:spPr/>
+      </p:sp>
+      <p:sp>
+        <p:nvSpPr>
+          <p:cNvPr id="3" name="Notes Placeholder 2"/>
+          <p:cNvSpPr>
+            <a:spLocks noGrp="1"/>
+          </p:cNvSpPr>
+          <p:nvPr>
+            <p:ph type="body" idx="1"/>
+          </p:nvPr>
+        </p:nvSpPr>
+        <p:spPr/>
+        <p:txBody>
+          <a:bodyPr/>
+          <a:lstStyle/>
+          <a:p>
+            <a:r>
+              <a:rPr lang="en-US" dirty="0"/>
+              <a:t>So if you see me around, come find me. I can show you the card. We can talk about Onshape, OpenSCAD, Python, gears, GitHub Actions, STEP files, licensing, cat toys, or how much tooling is too much tooling for a tiny plastic business card.
+The repo is jmcpheron slash pycon2026.
+Thank you.</a:t>
+            </a:r>
+            <a:endParaRPr lang="en-US" dirty="0"/>
+          </a:p>
+        </p:txBody>
+      </p:sp>
+      <p:sp>
+        <p:nvSpPr>
+          <p:cNvPr id="4" name="Slide Number Placeholder 3"/>
+          <p:cNvSpPr>
+            <a:spLocks noGrp="1"/>
+          </p:cNvSpPr>
+          <p:nvPr>
+            <p:ph type="sldNum" sz="quarter" idx="10"/>
+          </p:nvPr>
+        </p:nvSpPr>
+        <p:spPr/>
+        <p:txBody>
+          <a:bodyPr/>
+          <a:lstStyle/>
+          <a:p>
+            <a:fld id="{F7021451-1387-4CA6-816F-3879F97B5CBC}" type="slidenum">
+              <a:rPr lang="en-US"/>
+              <a:t>12</a:t>
             </a:fld>
             <a:endParaRPr lang="en-US"/>
           </a:p>
@@ -776,7 +869,11 @@
           <a:p>
             <a:r>
               <a:rPr lang="en-US" dirty="0"/>
-              <a:t>Two printed halves, five compound gears snapping into pockets, a small pinion sticking out the right edge for your thumb. I wanted something I could hand people and use as an excuse to start conversations.</a:t>
+              <a:t>I work in IT for a community college here in California, mostly around student systems.
+But this talk is about one of my hobbies, which is 3D printing little mechanical things and then overthinking them with Python.
+This is my first PyCon, and I wanted to make something physical to bring with me.
+Partly because 3D printing is fun. Partly because I like making small mechanical objects. And partly because conferences full of strangers can be a little intimidating, so I wanted a conversation starter.
+Something I could hand someone that was more interesting than just saying, "Here's my GitHub."</a:t>
             </a:r>
             <a:endParaRPr lang="en-US" dirty="0"/>
           </a:p>
@@ -864,7 +961,10 @@
           <a:p>
             <a:r>
               <a:rPr lang="en-US" dirty="0"/>
-              <a:t>Each pinion drives the next big gear. 10 teeth into 40 is 4:1. Four meshes in a row gives you 4 to the fourth: 256. In this animation the input gear on the left is a blur; the output gear on the right barely twitches. You'd need to move your thumb about 45 metres — the length of a pool — to rotate it once.</a:t>
+              <a:t>It has my GitHub project on it, but it also has a tiny gear mechanism built into it. You can spin one gear with your thumb, and the motion moves through the card.
+It is part business card, part fidget toy, and part tiny mechanical demo.
+At first, that was the whole project. Make a cool little object. Print it. Bring it to PyCon. Use it as an excuse to talk to people.
+But then I had the thought that probably gets a lot of us into trouble: How can I make this a Python project?</a:t>
             </a:r>
             <a:endParaRPr lang="en-US" dirty="0"/>
           </a:p>
@@ -952,7 +1052,9 @@
           <a:p>
             <a:r>
               <a:rPr lang="en-US" dirty="0"/>
-              <a:t>If you put all five gears at the same vertical level, the big discs physically overlap at the mesh point — nothing turns. The obvious fix is a descending staircase, but then the card keeps getting thicker with each gear you add. The actual solution is a 3-level cycle: two standard gears, then one tall-hub variant that vaults back to level zero. Five gears, ten gears, doesn't matter — still three levels, still five millimetres.</a:t>
+              <a:t>The design itself started in Onshape. I'm still new enough to Onshape that a lot of this was just me learning how to build parts, assemble them, line things up, and think about whether a design would actually print and move.
+Once I had the card assembled, I exported it as a STEP file.
+That was the moment where the project changed for me. Because now I had a single file that represented the assembled physical object. I could put that file in a GitHub repo. I could version it. I could run tools against it. I could start treating the physical object a little more like a software project.</a:t>
             </a:r>
             <a:endParaRPr lang="en-US" dirty="0"/>
           </a:p>
@@ -1040,7 +1142,10 @@
           <a:p>
             <a:r>
               <a:rPr lang="en-US" dirty="0"/>
-              <a:t>When Onshape exports STEP it strips everything parametric — no tooth counts, no module, just named geometry. So I wrote a page that recovers design intent from raw geometry. Slice the STL, sample the radial profile around the gear axis, FFT it. One spike at bin 40. That's your tooth count. The math just works, no special signal processing libraries, just numpy.</a:t>
+              <a:t>So the Python part became less about replacing CAD, and more about building tooling around the CAD export. The design still happens in Onshape. But once the STEP file is in the repo, Python can start doing useful things around it.
+It can inspect the file. It can help take the assembly apart. It can generate renders. It can make exploded views. It can create animated GIFs that show the mechanism moving.
+And it can help keep track of all the little notes around the object: explainers, development journals, tolerance problems, print settings, experiments, and the general story of how the thing changed over time.
+That became the real project. Not just the card itself, but the workflow around the card.</a:t>
             </a:r>
             <a:endParaRPr lang="en-US" dirty="0"/>
           </a:p>
@@ -1128,7 +1233,10 @@
           <a:p>
             <a:r>
               <a:rPr lang="en-US" dirty="0"/>
-              <a:t>cardlab takes the STEP file and produces 3D renders, an exploded GIF, and a parts manifest. explainers goes the other direction: reads a single constants file and emits all the diagrams and markdown pages. Change one number, CI regenerates everything.</a:t>
+              <a:t>A lot of 3D printing projects end up as a pile of files. You might have an STL. Maybe a screenshot. Maybe a README. Maybe some notes about tolerances or print settings. But it can be hard to understand what the object is, how it works, what changed, and which files matter.
+A STEP file is useful, but it is not an explanation. Most people do not want to download a CAD viewer just to understand a tiny conference object.
+So I started thinking about the repo as something that should help the object explain itself.
+The input is the STEP file. Then Python glues together different tools and generates the supporting material around it. Renders. Exploded views. Animations. Diagrams. Notes about what failed. Notes about what I had to change because the printer, very rudely, obeys physics.</a:t>
             </a:r>
             <a:endParaRPr lang="en-US" dirty="0"/>
           </a:p>
@@ -1216,7 +1324,11 @@
           <a:p>
             <a:r>
               <a:rPr lang="en-US" dirty="0"/>
-              <a:t>The constants file is the single source of truth. Those five lines define the entire gear geometry. The test suite even enforces that no explainer page contains a hardcoded literal — if you hardcode 40 instead of card.BIG_TEETH, CI catches it. Change N_STAGES to 6 and CI regenerates a 1024:1 card.</a:t>
+              <a:t>And that is where GitHub Actions became interesting. Normally, when I think about CI, I think about tests passing, packages building, or docs being published.
+But with a 3D object, the build output can be visual. It can be an exploded view. It can be a render. It can be an animation. It can be a GIF of a tiny gearbox moving. And that feels weirdly delightful to me.
+Because now the repo is not just storing the design. The repo is generating evidence about the design.
+Screenshots get stale. Documentation gets stale. Images in a README can quietly stop matching the actual object. That happens in software all the time, and it definitely happens in 3D printing projects. You make a change, export a new file, forget to update the image, and now the repo is lying a little bit.
+So this project is partly about making that harder.</a:t>
             </a:r>
             <a:endParaRPr lang="en-US" dirty="0"/>
           </a:p>
@@ -1304,7 +1416,10 @@
           <a:p>
             <a:r>
               <a:rPr lang="en-US" dirty="0"/>
-              <a:t>Three workflows run automatically. They write to completely separate paths so they never conflict. Push a new Onshape export and the hero GIF updates within a minute. I haven't touched any of those generated files by hand.</a:t>
+              <a:t>Before this card, I had another little Onshape project. For Christmas, my mom asked me to design a 3D printed cat toy. That project is where I really started learning how much I enjoy making separate parts in Onshape and then assembling them into a complete object.
+There is something extremely satisfying about designing individual pieces, bringing them together, and then seeing the assembled product. It feels like the model becomes real before you ever print it.
+The only problem is that I do not have a cat. I have a golden retriever named Bowie.
+But that cat toy became useful for the Python side of the project too. It was a different STEP file. A different object. A different assembly. And I could try running it through a similar workflow. That helped me think about whether I was building tools for one very specific business card, or whether I was building a more general little pipeline for understanding 3D projects.</a:t>
             </a:r>
             <a:endParaRPr lang="en-US" dirty="0"/>
           </a:p>
@@ -1392,7 +1507,9 @@
           <a:p>
             <a:r>
               <a:rPr lang="en-US" dirty="0"/>
-              <a:t>The hard part wasn't the gear design — it was making the tooling explain what the physical object is doing. The FFT tooth-counting is the one moment where I thought: okay, this is actually a little clever. And card.py turned out to be the most useful document in the whole project.</a:t>
+              <a:t>I do not want to oversell this. I am sure that in serious hardware, robotics, aerospace, manufacturing, and embedded systems, there are much more mature ways to do this. There are probably industry-standard workflows, best practices, blind spots I have not even learned enough to know I have, and whole categories of tooling that solve parts of this properly.
+My version is the tiny plastic maker version. It is a 3D printed gearbox business card, a public Onshape model, a STEP export, a Python CLI, and GitHub Actions making pictures.
+But that is what I like about it. It is small enough to be playful. It is silly enough to experiment with. And it points at a serious idea.</a:t>
             </a:r>
             <a:endParaRPr lang="en-US" dirty="0"/>
           </a:p>
@@ -1822,6 +1939,45 @@
 <file path=ppt/slides/slide11.xml><?xml version="1.0" encoding="utf-8"?>
 <p:sld xmlns:a="http://schemas.openxmlformats.org/drawingml/2006/main" xmlns:r="http://schemas.openxmlformats.org/officeDocument/2006/relationships" xmlns:p="http://schemas.openxmlformats.org/presentationml/2006/main">
   <p:cSld name="Slide 11">
+    <p:bg>
+      <p:bgPr>
+        <a:blipFill dpi="0" rotWithShape="1">
+          <a:blip r:embed="rId1">
+            <a:lum/>
+          </a:blip>
+          <a:srcRect/>
+          <a:stretch>
+            <a:fillRect/>
+          </a:stretch>
+        </a:blipFill>
+        <a:effectLst/>
+      </p:bgPr>
+    </p:bg>
+    <p:spTree>
+      <p:nvGrpSpPr>
+        <p:cNvPr id="1" name=""/>
+        <p:cNvGrpSpPr/>
+        <p:nvPr/>
+      </p:nvGrpSpPr>
+      <p:grpSpPr>
+        <a:xfrm>
+          <a:off x="0" y="0"/>
+          <a:ext cx="0" cy="0"/>
+          <a:chOff x="0" y="0"/>
+          <a:chExt cx="0" cy="0"/>
+        </a:xfrm>
+      </p:grpSpPr>
+    </p:spTree>
+  </p:cSld>
+  <p:clrMapOvr>
+    <a:masterClrMapping/>
+  </p:clrMapOvr>
+</p:sld>
+</file>
+
+<file path=ppt/slides/slide12.xml><?xml version="1.0" encoding="utf-8"?>
+<p:sld xmlns:a="http://schemas.openxmlformats.org/drawingml/2006/main" xmlns:r="http://schemas.openxmlformats.org/officeDocument/2006/relationships" xmlns:p="http://schemas.openxmlformats.org/presentationml/2006/main">
+  <p:cSld name="Slide 12">
     <p:bg>
       <p:bgPr>
         <a:blipFill dpi="0" rotWithShape="1">

</xml_diff>